<commit_message>
Deploy: depo ve dosya adlarında tek kural
</commit_message>
<xml_diff>
--- a/en/project-guide/cen429-proje-rehberi-sunum.pptx
+++ b/en/project-guide/cen429-proje-rehberi-sunum.pptx
@@ -4745,7 +4745,7 @@
                 </a:solidFill>
                 <a:latin typeface="Consolas"/>
               </a:rPr>
-              <a:t>cen429-project-name-surname-cpp</a:t>
+              <a:t>cen429-2026-2027-NNN-name-surname-cpp</a:t>
             </a:r>
             <a:r>
               <a:rPr sz="2000" b="0">
@@ -15603,7 +15603,7 @@
                 </a:solidFill>
                 <a:latin typeface="Consolas"/>
               </a:rPr>
-              <a:t>cen429-midterm-name-surname.zip           # final: cen429-final-name-surname.zip</a:t>
+              <a:t>cen429-2026-2027-NNN-midterm.zip           # final: cen429-2026-2027-NNN-final.zip</a:t>
             </a:r>
           </a:p>
           <a:p>
@@ -15615,7 +15615,7 @@
                 </a:solidFill>
                 <a:latin typeface="Consolas"/>
               </a:rPr>
-              <a:t>└── cen429-project-name-surname-cpp/      # clone of the GitHub repo</a:t>
+              <a:t>└── cen429-2026-2027-NNN-name-surname-cpp/      # clone of the GitHub repo</a:t>
             </a:r>
           </a:p>
           <a:p>
@@ -15949,7 +15949,7 @@
                 </a:solidFill>
                 <a:latin typeface="Consolas"/>
               </a:rPr>
-              <a:t>cen429-project-name-surname-cpp</a:t>
+              <a:t>cen429-2026-2027-NNN-name-surname-cpp</a:t>
             </a:r>
           </a:p>
           <a:p>
@@ -15989,7 +15989,7 @@
                 </a:solidFill>
                 <a:latin typeface="Consolas"/>
               </a:rPr>
-              <a:t>cen429-midterm-name-surname.zip</a:t>
+              <a:t>cen429-2026-2027-NNN-midterm.zip</a:t>
             </a:r>
             <a:r>
               <a:rPr sz="2000" b="0">
@@ -16006,7 +16006,7 @@
                 </a:solidFill>
                 <a:latin typeface="Consolas"/>
               </a:rPr>
-              <a:t>cen429-final-name-surname.zip</a:t>
+              <a:t>cen429-2026-2027-NNN-final.zip</a:t>
             </a:r>
           </a:p>
           <a:p>
@@ -16046,7 +16046,7 @@
                 </a:solidFill>
                 <a:latin typeface="Consolas"/>
               </a:rPr>
-              <a:t>cen429-security-guide-name-surname.docx</a:t>
+              <a:t>cen429-2026-2027-NNN-security-guide.docx</a:t>
             </a:r>
           </a:p>
         </p:txBody>
@@ -20602,7 +20602,7 @@
                   <a:srgbClr val="1F2D3A"/>
                 </a:solidFill>
               </a:rPr>
-              <a:t>instructor a collaborator? Do both members have commits?</a:t>
+              <a:t>instructor a collaborator? Does every member have commits?</a:t>
             </a:r>
           </a:p>
         </p:txBody>

</xml_diff>